<commit_message>
Move Executive Dashboard content to Future Scope in the deck
Everything not actually reachable in this review's demo scope now lives
in Future Scope instead: replaced the Executive Dashboard slide with a
Test Case Simulator slide (a real, working feature), and scrubbed
"executive" mentions from the architecture, requirement-mapping, and
solution-overview slides.
</commit_message>
<xml_diff>
--- a/Virgil_Presentation.pptx
+++ b/Virgil_Presentation.pptx
@@ -2637,7 +2637,7 @@
                 <a:ea typeface="Calibri" pitchFamily="34" charset="-122"/>
                 <a:cs typeface="Calibri" pitchFamily="34" charset="-120"/>
               </a:rPr>
-              <a:t>Pre-transaction risk scoring  ·  device &amp; network intelligence  ·  analyst &amp; executive consoles</a:t>
+              <a:t>Pre-transaction risk scoring  ·  device &amp; network intelligence  ·  analyst investigation console</a:t>
             </a:r>
             <a:endParaRPr lang="en-US" sz="1250" dirty="0"/>
           </a:p>
@@ -3789,7 +3789,7 @@
                 <a:ea typeface="Calibri" pitchFamily="34" charset="-122"/>
                 <a:cs typeface="Calibri" pitchFamily="34" charset="-120"/>
               </a:rPr>
-              <a:t>Analyst console (alerts, cases, fund-flow graph) + executive KPI dashboard</a:t>
+              <a:t>Analyst console — alert inbox, investigation cases, and an interactive fund-flow graph</a:t>
             </a:r>
             <a:endParaRPr lang="en-US" sz="1100" dirty="0"/>
           </a:p>
@@ -4985,7 +4985,7 @@
                 <a:ea typeface="Calibri" pitchFamily="34" charset="-122"/>
                 <a:cs typeface="Calibri" pitchFamily="34" charset="-120"/>
               </a:rPr>
-              <a:t>FOR LEADERSHIP</a:t>
+              <a:t>PROOF, NOT PROMISES</a:t>
             </a:r>
             <a:endParaRPr lang="en-US" sz="1300" dirty="0"/>
           </a:p>
@@ -5016,7 +5016,7 @@
               <a:buNone/>
             </a:pPr>
             <a:r>
-              <a:rPr lang="en-US" sz="3200" b="1" dirty="0">
+              <a:rPr lang="en-US" sz="3000" b="1" dirty="0">
                 <a:solidFill>
                   <a:srgbClr val="F1F5F9"/>
                 </a:solidFill>
@@ -5024,9 +5024,9 @@
                 <a:ea typeface="Calibri" pitchFamily="34" charset="-122"/>
                 <a:cs typeface="Calibri" pitchFamily="34" charset="-120"/>
               </a:rPr>
-              <a:t>Executive Dashboard</a:t>
-            </a:r>
-            <a:endParaRPr lang="en-US" sz="3200" dirty="0"/>
+              <a:t>Built-In Test Case Simulator</a:t>
+            </a:r>
+            <a:endParaRPr lang="en-US" sz="3000" dirty="0"/>
           </a:p>
         </p:txBody>
       </p:sp>
@@ -5039,7 +5039,7 @@
         <p:spPr>
           <a:xfrm>
             <a:off x="640080" y="1417320"/>
-            <a:ext cx="10881360" cy="365760"/>
+            <a:ext cx="10881360" cy="502920"/>
           </a:xfrm>
           <a:prstGeom prst="rect">
             <a:avLst/>
@@ -5052,6 +5052,9 @@
           <a:lstStyle/>
           <a:p>
             <a:pPr indent="0" marL="0">
+              <a:lnSpc>
+                <a:spcPct val="120000"/>
+              </a:lnSpc>
               <a:buNone/>
             </a:pPr>
             <a:r>
@@ -5063,7 +5066,7 @@
                 <a:ea typeface="Calibri" pitchFamily="34" charset="-122"/>
                 <a:cs typeface="Calibri" pitchFamily="34" charset="-120"/>
               </a:rPr>
-              <a:t>Board-level visibility into fraud exposure, regulatory posture, and model health — no transaction-level detail required.</a:t>
+              <a:t>A one-click scenario runner at /demo — every card fires a real POST request against the real scoring engine, with real seeded accounts. Nothing here is a screenshot or a script.</a:t>
             </a:r>
             <a:endParaRPr lang="en-US" sz="1300" dirty="0"/>
           </a:p>
@@ -5077,12 +5080,12 @@
         </p:nvSpPr>
         <p:spPr>
           <a:xfrm>
-            <a:off x="640080" y="1965960"/>
-            <a:ext cx="2606040" cy="1371600"/>
+            <a:off x="640080" y="2148840"/>
+            <a:ext cx="3502152" cy="2606040"/>
           </a:xfrm>
           <a:prstGeom prst="roundRect">
             <a:avLst>
-              <a:gd name="adj" fmla="val 5333"/>
+              <a:gd name="adj" fmla="val 2807"/>
             </a:avLst>
           </a:prstGeom>
           <a:solidFill>
@@ -5096,9 +5099,29 @@
           </a:ln>
         </p:spPr>
       </p:sp>
+      <p:sp>
+        <p:nvSpPr>
+          <p:cNvPr id="6" name="Shape 4"/>
+          <p:cNvSpPr/>
+          <p:nvPr/>
+        </p:nvSpPr>
+        <p:spPr>
+          <a:xfrm>
+            <a:off x="896112" y="2423160"/>
+            <a:ext cx="621792" cy="621792"/>
+          </a:xfrm>
+          <a:prstGeom prst="ellipse">
+            <a:avLst/>
+          </a:prstGeom>
+          <a:solidFill>
+            <a:srgbClr val="1D3B66"/>
+          </a:solidFill>
+          <a:ln/>
+        </p:spPr>
+      </p:sp>
       <p:pic>
         <p:nvPicPr>
-          <p:cNvPr id="6" name="Image 0" descr="C:\Users\Dell\AppData\Local\Temp\claude\C--Users-Dell-Documents-chakravyuh\a4ec3c1a-964e-4574-a792-caf74a383059\scratchpad\virgil_ppt\icons\rupee.png">    </p:cNvPr>
+          <p:cNvPr id="7" name="Image 0" descr="C:\Users\Dell\AppData\Local\Temp\claude\C--Users-Dell-Documents-chakravyuh\a4ec3c1a-964e-4574-a792-caf74a383059\scratchpad\virgil_ppt\icons\zap.png">    </p:cNvPr>
           <p:cNvPicPr>
             <a:picLocks noChangeAspect="1"/>
           </p:cNvPicPr>
@@ -5112,8 +5135,8 @@
         </p:blipFill>
         <p:spPr>
           <a:xfrm>
-            <a:off x="841248" y="2167128"/>
-            <a:ext cx="365760" cy="365760"/>
+            <a:off x="1057778" y="2584826"/>
+            <a:ext cx="298460" cy="298460"/>
           </a:xfrm>
           <a:prstGeom prst="rect">
             <a:avLst/>
@@ -5122,14 +5145,53 @@
       </p:pic>
       <p:sp>
         <p:nvSpPr>
-          <p:cNvPr id="7" name="Text 4"/>
-          <p:cNvSpPr txBox="1"/>
-          <p:nvPr/>
-        </p:nvSpPr>
-        <p:spPr>
-          <a:xfrm>
-            <a:off x="822960" y="2514600"/>
-            <a:ext cx="2240280" cy="502920"/>
+          <p:cNvPr id="8" name="Text 5"/>
+          <p:cNvSpPr txBox="1"/>
+          <p:nvPr/>
+        </p:nvSpPr>
+        <p:spPr>
+          <a:xfrm>
+            <a:off x="3090672" y="2404872"/>
+            <a:ext cx="822960" cy="658368"/>
+          </a:xfrm>
+          <a:prstGeom prst="rect">
+            <a:avLst/>
+          </a:prstGeom>
+          <a:noFill/>
+          <a:ln/>
+        </p:spPr>
+        <p:txBody>
+          <a:bodyPr wrap="square" lIns="0" tIns="0" rIns="0" bIns="0" rtlCol="0" anchor="ctr"/>
+          <a:lstStyle/>
+          <a:p>
+            <a:pPr algn="r" indent="0" marL="0">
+              <a:buNone/>
+            </a:pPr>
+            <a:r>
+              <a:rPr lang="en-US" sz="3000" b="1" dirty="0">
+                <a:solidFill>
+                  <a:srgbClr val="3B82F6"/>
+                </a:solidFill>
+                <a:latin typeface="Calibri" pitchFamily="34" charset="0"/>
+                <a:ea typeface="Calibri" pitchFamily="34" charset="-122"/>
+                <a:cs typeface="Calibri" pitchFamily="34" charset="-120"/>
+              </a:rPr>
+              <a:t>9</a:t>
+            </a:r>
+            <a:endParaRPr lang="en-US" sz="3000" dirty="0"/>
+          </a:p>
+        </p:txBody>
+      </p:sp>
+      <p:sp>
+        <p:nvSpPr>
+          <p:cNvPr id="9" name="Text 6"/>
+          <p:cNvSpPr txBox="1"/>
+          <p:nvPr/>
+        </p:nvSpPr>
+        <p:spPr>
+          <a:xfrm>
+            <a:off x="896112" y="3246120"/>
+            <a:ext cx="2990088" cy="548640"/>
           </a:xfrm>
           <a:prstGeom prst="rect">
             <a:avLst/>
@@ -5142,33 +5204,36 @@
           <a:lstStyle/>
           <a:p>
             <a:pPr indent="0" marL="0">
-              <a:buNone/>
-            </a:pPr>
-            <a:r>
-              <a:rPr lang="en-US" sz="2200" b="1" dirty="0">
-                <a:solidFill>
-                  <a:srgbClr val="3B82F6"/>
-                </a:solidFill>
-                <a:latin typeface="Calibri" pitchFamily="34" charset="0"/>
-                <a:ea typeface="Calibri" pitchFamily="34" charset="-122"/>
-                <a:cs typeface="Calibri" pitchFamily="34" charset="-120"/>
-              </a:rPr>
-              <a:t>₹8.99 Cr</a:t>
-            </a:r>
-            <a:endParaRPr lang="en-US" sz="2200" dirty="0"/>
-          </a:p>
-        </p:txBody>
-      </p:sp>
-      <p:sp>
-        <p:nvSpPr>
-          <p:cNvPr id="8" name="Text 5"/>
-          <p:cNvSpPr txBox="1"/>
-          <p:nvPr/>
-        </p:nvSpPr>
-        <p:spPr>
-          <a:xfrm>
-            <a:off x="822960" y="2990088"/>
-            <a:ext cx="2240280" cy="274320"/>
+              <a:lnSpc>
+                <a:spcPct val="110000"/>
+              </a:lnSpc>
+              <a:buNone/>
+            </a:pPr>
+            <a:r>
+              <a:rPr lang="en-US" sz="1450" b="1" dirty="0">
+                <a:solidFill>
+                  <a:srgbClr val="F1F5F9"/>
+                </a:solidFill>
+                <a:latin typeface="Calibri" pitchFamily="34" charset="0"/>
+                <a:ea typeface="Calibri" pitchFamily="34" charset="-122"/>
+                <a:cs typeface="Calibri" pitchFamily="34" charset="-120"/>
+              </a:rPr>
+              <a:t>Pre-Transaction Prevention</a:t>
+            </a:r>
+            <a:endParaRPr lang="en-US" sz="1450" dirty="0"/>
+          </a:p>
+        </p:txBody>
+      </p:sp>
+      <p:sp>
+        <p:nvSpPr>
+          <p:cNvPr id="10" name="Text 7"/>
+          <p:cNvSpPr txBox="1"/>
+          <p:nvPr/>
+        </p:nvSpPr>
+        <p:spPr>
+          <a:xfrm>
+            <a:off x="896112" y="3840480"/>
+            <a:ext cx="2990088" cy="777240"/>
           </a:xfrm>
           <a:prstGeom prst="rect">
             <a:avLst/>
@@ -5181,10 +5246,13 @@
           <a:lstStyle/>
           <a:p>
             <a:pPr indent="0" marL="0">
-              <a:buNone/>
-            </a:pPr>
-            <a:r>
-              <a:rPr lang="en-US" sz="1000" dirty="0">
+              <a:lnSpc>
+                <a:spcPct val="125000"/>
+              </a:lnSpc>
+              <a:buNone/>
+            </a:pPr>
+            <a:r>
+              <a:rPr lang="en-US" sz="1100" dirty="0">
                 <a:solidFill>
                   <a:srgbClr val="94A3B8"/>
                 </a:solidFill>
@@ -5192,26 +5260,26 @@
                 <a:ea typeface="Calibri" pitchFamily="34" charset="-122"/>
                 <a:cs typeface="Calibri" pitchFamily="34" charset="-120"/>
               </a:rPr>
-              <a:t>Fraud Detected YTD</a:t>
-            </a:r>
-            <a:endParaRPr lang="en-US" sz="1000" dirty="0"/>
-          </a:p>
-        </p:txBody>
-      </p:sp>
-      <p:sp>
-        <p:nvSpPr>
-          <p:cNvPr id="9" name="Shape 6"/>
+              <a:t>Amount, device, beneficiary, and structuring scenarios</a:t>
+            </a:r>
+            <a:endParaRPr lang="en-US" sz="1100" dirty="0"/>
+          </a:p>
+        </p:txBody>
+      </p:sp>
+      <p:sp>
+        <p:nvSpPr>
+          <p:cNvPr id="11" name="Shape 8"/>
           <p:cNvSpPr/>
           <p:nvPr/>
         </p:nvSpPr>
         <p:spPr>
           <a:xfrm>
-            <a:off x="3447288" y="1965960"/>
-            <a:ext cx="2606040" cy="1371600"/>
+            <a:off x="4325112" y="2148840"/>
+            <a:ext cx="3502152" cy="2606040"/>
           </a:xfrm>
           <a:prstGeom prst="roundRect">
             <a:avLst>
-              <a:gd name="adj" fmla="val 5333"/>
+              <a:gd name="adj" fmla="val 2807"/>
             </a:avLst>
           </a:prstGeom>
           <a:solidFill>
@@ -5225,9 +5293,29 @@
           </a:ln>
         </p:spPr>
       </p:sp>
+      <p:sp>
+        <p:nvSpPr>
+          <p:cNvPr id="12" name="Shape 9"/>
+          <p:cNvSpPr/>
+          <p:nvPr/>
+        </p:nvSpPr>
+        <p:spPr>
+          <a:xfrm>
+            <a:off x="4581144" y="2423160"/>
+            <a:ext cx="621792" cy="621792"/>
+          </a:xfrm>
+          <a:prstGeom prst="ellipse">
+            <a:avLst/>
+          </a:prstGeom>
+          <a:solidFill>
+            <a:srgbClr val="1D3B66"/>
+          </a:solidFill>
+          <a:ln/>
+        </p:spPr>
+      </p:sp>
       <p:pic>
         <p:nvPicPr>
-          <p:cNvPr id="10" name="Image 1" descr="C:\Users\Dell\AppData\Local\Temp\claude\C--Users-Dell-Documents-chakravyuh\a4ec3c1a-964e-4574-a792-caf74a383059\scratchpad\virgil_ppt\icons\shield.png">    </p:cNvPr>
+          <p:cNvPr id="13" name="Image 1" descr="C:\Users\Dell\AppData\Local\Temp\claude\C--Users-Dell-Documents-chakravyuh\a4ec3c1a-964e-4574-a792-caf74a383059\scratchpad\virgil_ppt\icons\network.png">    </p:cNvPr>
           <p:cNvPicPr>
             <a:picLocks noChangeAspect="1"/>
           </p:cNvPicPr>
@@ -5241,8 +5329,8 @@
         </p:blipFill>
         <p:spPr>
           <a:xfrm>
-            <a:off x="3648456" y="2167128"/>
-            <a:ext cx="365760" cy="365760"/>
+            <a:off x="4742810" y="2584826"/>
+            <a:ext cx="298460" cy="298460"/>
           </a:xfrm>
           <a:prstGeom prst="rect">
             <a:avLst/>
@@ -5251,14 +5339,53 @@
       </p:pic>
       <p:sp>
         <p:nvSpPr>
-          <p:cNvPr id="11" name="Text 7"/>
-          <p:cNvSpPr txBox="1"/>
-          <p:nvPr/>
-        </p:nvSpPr>
-        <p:spPr>
-          <a:xfrm>
-            <a:off x="3630168" y="2514600"/>
-            <a:ext cx="2240280" cy="502920"/>
+          <p:cNvPr id="14" name="Text 10"/>
+          <p:cNvSpPr txBox="1"/>
+          <p:nvPr/>
+        </p:nvSpPr>
+        <p:spPr>
+          <a:xfrm>
+            <a:off x="6775704" y="2404872"/>
+            <a:ext cx="822960" cy="658368"/>
+          </a:xfrm>
+          <a:prstGeom prst="rect">
+            <a:avLst/>
+          </a:prstGeom>
+          <a:noFill/>
+          <a:ln/>
+        </p:spPr>
+        <p:txBody>
+          <a:bodyPr wrap="square" lIns="0" tIns="0" rIns="0" bIns="0" rtlCol="0" anchor="ctr"/>
+          <a:lstStyle/>
+          <a:p>
+            <a:pPr algn="r" indent="0" marL="0">
+              <a:buNone/>
+            </a:pPr>
+            <a:r>
+              <a:rPr lang="en-US" sz="3000" b="1" dirty="0">
+                <a:solidFill>
+                  <a:srgbClr val="3B82F6"/>
+                </a:solidFill>
+                <a:latin typeface="Calibri" pitchFamily="34" charset="0"/>
+                <a:ea typeface="Calibri" pitchFamily="34" charset="-122"/>
+                <a:cs typeface="Calibri" pitchFamily="34" charset="-120"/>
+              </a:rPr>
+              <a:t>9</a:t>
+            </a:r>
+            <a:endParaRPr lang="en-US" sz="3000" dirty="0"/>
+          </a:p>
+        </p:txBody>
+      </p:sp>
+      <p:sp>
+        <p:nvSpPr>
+          <p:cNvPr id="15" name="Text 11"/>
+          <p:cNvSpPr txBox="1"/>
+          <p:nvPr/>
+        </p:nvSpPr>
+        <p:spPr>
+          <a:xfrm>
+            <a:off x="4581144" y="3246120"/>
+            <a:ext cx="2990088" cy="548640"/>
           </a:xfrm>
           <a:prstGeom prst="rect">
             <a:avLst/>
@@ -5271,33 +5398,36 @@
           <a:lstStyle/>
           <a:p>
             <a:pPr indent="0" marL="0">
-              <a:buNone/>
-            </a:pPr>
-            <a:r>
-              <a:rPr lang="en-US" sz="2200" b="1" dirty="0">
-                <a:solidFill>
-                  <a:srgbClr val="3B82F6"/>
-                </a:solidFill>
-                <a:latin typeface="Calibri" pitchFamily="34" charset="0"/>
-                <a:ea typeface="Calibri" pitchFamily="34" charset="-122"/>
-                <a:cs typeface="Calibri" pitchFamily="34" charset="-120"/>
-              </a:rPr>
-              <a:t>₹11.78 Cr</a:t>
-            </a:r>
-            <a:endParaRPr lang="en-US" sz="2200" dirty="0"/>
-          </a:p>
-        </p:txBody>
-      </p:sp>
-      <p:sp>
-        <p:nvSpPr>
-          <p:cNvPr id="12" name="Text 8"/>
-          <p:cNvSpPr txBox="1"/>
-          <p:nvPr/>
-        </p:nvSpPr>
-        <p:spPr>
-          <a:xfrm>
-            <a:off x="3630168" y="2990088"/>
-            <a:ext cx="2240280" cy="274320"/>
+              <a:lnSpc>
+                <a:spcPct val="110000"/>
+              </a:lnSpc>
+              <a:buNone/>
+            </a:pPr>
+            <a:r>
+              <a:rPr lang="en-US" sz="1450" b="1" dirty="0">
+                <a:solidFill>
+                  <a:srgbClr val="F1F5F9"/>
+                </a:solidFill>
+                <a:latin typeface="Calibri" pitchFamily="34" charset="0"/>
+                <a:ea typeface="Calibri" pitchFamily="34" charset="-122"/>
+                <a:cs typeface="Calibri" pitchFamily="34" charset="-120"/>
+              </a:rPr>
+              <a:t>Post-Transaction Investigation</a:t>
+            </a:r>
+            <a:endParaRPr lang="en-US" sz="1450" dirty="0"/>
+          </a:p>
+        </p:txBody>
+      </p:sp>
+      <p:sp>
+        <p:nvSpPr>
+          <p:cNvPr id="16" name="Text 12"/>
+          <p:cNvSpPr txBox="1"/>
+          <p:nvPr/>
+        </p:nvSpPr>
+        <p:spPr>
+          <a:xfrm>
+            <a:off x="4581144" y="3840480"/>
+            <a:ext cx="2990088" cy="777240"/>
           </a:xfrm>
           <a:prstGeom prst="rect">
             <a:avLst/>
@@ -5310,10 +5440,13 @@
           <a:lstStyle/>
           <a:p>
             <a:pPr indent="0" marL="0">
-              <a:buNone/>
-            </a:pPr>
-            <a:r>
-              <a:rPr lang="en-US" sz="1000" dirty="0">
+              <a:lnSpc>
+                <a:spcPct val="125000"/>
+              </a:lnSpc>
+              <a:buNone/>
+            </a:pPr>
+            <a:r>
+              <a:rPr lang="en-US" sz="1100" dirty="0">
                 <a:solidFill>
                   <a:srgbClr val="94A3B8"/>
                 </a:solidFill>
@@ -5321,26 +5454,26 @@
                 <a:ea typeface="Calibri" pitchFamily="34" charset="-122"/>
                 <a:cs typeface="Calibri" pitchFamily="34" charset="-120"/>
               </a:rPr>
-              <a:t>Fraud Prevented</a:t>
-            </a:r>
-            <a:endParaRPr lang="en-US" sz="1000" dirty="0"/>
-          </a:p>
-        </p:txBody>
-      </p:sp>
-      <p:sp>
-        <p:nvSpPr>
-          <p:cNvPr id="13" name="Shape 9"/>
+              <a:t>Circular transfers, layering, mule-network patterns</a:t>
+            </a:r>
+            <a:endParaRPr lang="en-US" sz="1100" dirty="0"/>
+          </a:p>
+        </p:txBody>
+      </p:sp>
+      <p:sp>
+        <p:nvSpPr>
+          <p:cNvPr id="17" name="Shape 13"/>
           <p:cNvSpPr/>
           <p:nvPr/>
         </p:nvSpPr>
         <p:spPr>
           <a:xfrm>
-            <a:off x="6254496" y="1965960"/>
-            <a:ext cx="2606040" cy="1371600"/>
+            <a:off x="8010144" y="2148840"/>
+            <a:ext cx="3502152" cy="2606040"/>
           </a:xfrm>
           <a:prstGeom prst="roundRect">
             <a:avLst>
-              <a:gd name="adj" fmla="val 5333"/>
+              <a:gd name="adj" fmla="val 2807"/>
             </a:avLst>
           </a:prstGeom>
           <a:solidFill>
@@ -5354,9 +5487,29 @@
           </a:ln>
         </p:spPr>
       </p:sp>
+      <p:sp>
+        <p:nvSpPr>
+          <p:cNvPr id="18" name="Shape 14"/>
+          <p:cNvSpPr/>
+          <p:nvPr/>
+        </p:nvSpPr>
+        <p:spPr>
+          <a:xfrm>
+            <a:off x="8266176" y="2423160"/>
+            <a:ext cx="621792" cy="621792"/>
+          </a:xfrm>
+          <a:prstGeom prst="ellipse">
+            <a:avLst/>
+          </a:prstGeom>
+          <a:solidFill>
+            <a:srgbClr val="1D3B66"/>
+          </a:solidFill>
+          <a:ln/>
+        </p:spPr>
+      </p:sp>
       <p:pic>
         <p:nvPicPr>
-          <p:cNvPr id="14" name="Image 2" descr="C:\Users\Dell\AppData\Local\Temp\claude\C--Users-Dell-Documents-chakravyuh\a4ec3c1a-964e-4574-a792-caf74a383059\scratchpad\virgil_ppt\icons\gauge.png">    </p:cNvPr>
+          <p:cNvPr id="19" name="Image 2" descr="C:\Users\Dell\AppData\Local\Temp\claude\C--Users-Dell-Documents-chakravyuh\a4ec3c1a-964e-4574-a792-caf74a383059\scratchpad\virgil_ppt\icons\layoutdashboard.png">    </p:cNvPr>
           <p:cNvPicPr>
             <a:picLocks noChangeAspect="1"/>
           </p:cNvPicPr>
@@ -5370,8 +5523,8 @@
         </p:blipFill>
         <p:spPr>
           <a:xfrm>
-            <a:off x="6455664" y="2167128"/>
-            <a:ext cx="365760" cy="365760"/>
+            <a:off x="8427842" y="2584826"/>
+            <a:ext cx="298460" cy="298460"/>
           </a:xfrm>
           <a:prstGeom prst="rect">
             <a:avLst/>
@@ -5380,14 +5533,53 @@
       </p:pic>
       <p:sp>
         <p:nvSpPr>
-          <p:cNvPr id="15" name="Text 10"/>
-          <p:cNvSpPr txBox="1"/>
-          <p:nvPr/>
-        </p:nvSpPr>
-        <p:spPr>
-          <a:xfrm>
-            <a:off x="6437376" y="2514600"/>
-            <a:ext cx="2240280" cy="502920"/>
+          <p:cNvPr id="20" name="Text 15"/>
+          <p:cNvSpPr txBox="1"/>
+          <p:nvPr/>
+        </p:nvSpPr>
+        <p:spPr>
+          <a:xfrm>
+            <a:off x="10460736" y="2404872"/>
+            <a:ext cx="822960" cy="658368"/>
+          </a:xfrm>
+          <a:prstGeom prst="rect">
+            <a:avLst/>
+          </a:prstGeom>
+          <a:noFill/>
+          <a:ln/>
+        </p:spPr>
+        <p:txBody>
+          <a:bodyPr wrap="square" lIns="0" tIns="0" rIns="0" bIns="0" rtlCol="0" anchor="ctr"/>
+          <a:lstStyle/>
+          <a:p>
+            <a:pPr algn="r" indent="0" marL="0">
+              <a:buNone/>
+            </a:pPr>
+            <a:r>
+              <a:rPr lang="en-US" sz="3000" b="1" dirty="0">
+                <a:solidFill>
+                  <a:srgbClr val="3B82F6"/>
+                </a:solidFill>
+                <a:latin typeface="Calibri" pitchFamily="34" charset="0"/>
+                <a:ea typeface="Calibri" pitchFamily="34" charset="-122"/>
+                <a:cs typeface="Calibri" pitchFamily="34" charset="-120"/>
+              </a:rPr>
+              <a:t>7</a:t>
+            </a:r>
+            <a:endParaRPr lang="en-US" sz="3000" dirty="0"/>
+          </a:p>
+        </p:txBody>
+      </p:sp>
+      <p:sp>
+        <p:nvSpPr>
+          <p:cNvPr id="21" name="Text 16"/>
+          <p:cNvSpPr txBox="1"/>
+          <p:nvPr/>
+        </p:nvSpPr>
+        <p:spPr>
+          <a:xfrm>
+            <a:off x="8266176" y="3246120"/>
+            <a:ext cx="2990088" cy="548640"/>
           </a:xfrm>
           <a:prstGeom prst="rect">
             <a:avLst/>
@@ -5400,33 +5592,36 @@
           <a:lstStyle/>
           <a:p>
             <a:pPr indent="0" marL="0">
-              <a:buNone/>
-            </a:pPr>
-            <a:r>
-              <a:rPr lang="en-US" sz="2200" b="1" dirty="0">
-                <a:solidFill>
-                  <a:srgbClr val="3B82F6"/>
-                </a:solidFill>
-                <a:latin typeface="Calibri" pitchFamily="34" charset="0"/>
-                <a:ea typeface="Calibri" pitchFamily="34" charset="-122"/>
-                <a:cs typeface="Calibri" pitchFamily="34" charset="-120"/>
-              </a:rPr>
-              <a:t>91.8%</a:t>
-            </a:r>
-            <a:endParaRPr lang="en-US" sz="2200" dirty="0"/>
-          </a:p>
-        </p:txBody>
-      </p:sp>
-      <p:sp>
-        <p:nvSpPr>
-          <p:cNvPr id="16" name="Text 11"/>
-          <p:cNvSpPr txBox="1"/>
-          <p:nvPr/>
-        </p:nvSpPr>
-        <p:spPr>
-          <a:xfrm>
-            <a:off x="6437376" y="2990088"/>
-            <a:ext cx="2240280" cy="274320"/>
+              <a:lnSpc>
+                <a:spcPct val="110000"/>
+              </a:lnSpc>
+              <a:buNone/>
+            </a:pPr>
+            <a:r>
+              <a:rPr lang="en-US" sz="1450" b="1" dirty="0">
+                <a:solidFill>
+                  <a:srgbClr val="F1F5F9"/>
+                </a:solidFill>
+                <a:latin typeface="Calibri" pitchFamily="34" charset="0"/>
+                <a:ea typeface="Calibri" pitchFamily="34" charset="-122"/>
+                <a:cs typeface="Calibri" pitchFamily="34" charset="-120"/>
+              </a:rPr>
+              <a:t>Analyst Dashboard Flows</a:t>
+            </a:r>
+            <a:endParaRPr lang="en-US" sz="1450" dirty="0"/>
+          </a:p>
+        </p:txBody>
+      </p:sp>
+      <p:sp>
+        <p:nvSpPr>
+          <p:cNvPr id="22" name="Text 17"/>
+          <p:cNvSpPr txBox="1"/>
+          <p:nvPr/>
+        </p:nvSpPr>
+        <p:spPr>
+          <a:xfrm>
+            <a:off x="8266176" y="3840480"/>
+            <a:ext cx="2990088" cy="777240"/>
           </a:xfrm>
           <a:prstGeom prst="rect">
             <a:avLst/>
@@ -5439,10 +5634,13 @@
           <a:lstStyle/>
           <a:p>
             <a:pPr indent="0" marL="0">
-              <a:buNone/>
-            </a:pPr>
-            <a:r>
-              <a:rPr lang="en-US" sz="1000" dirty="0">
+              <a:lnSpc>
+                <a:spcPct val="125000"/>
+              </a:lnSpc>
+              <a:buNone/>
+            </a:pPr>
+            <a:r>
+              <a:rPr lang="en-US" sz="1100" dirty="0">
                 <a:solidFill>
                   <a:srgbClr val="94A3B8"/>
                 </a:solidFill>
@@ -5450,26 +5648,26 @@
                 <a:ea typeface="Calibri" pitchFamily="34" charset="-122"/>
                 <a:cs typeface="Calibri" pitchFamily="34" charset="-120"/>
               </a:rPr>
-              <a:t>Detection Rate</a:t>
-            </a:r>
-            <a:endParaRPr lang="en-US" sz="1000" dirty="0"/>
-          </a:p>
-        </p:txBody>
-      </p:sp>
-      <p:sp>
-        <p:nvSpPr>
-          <p:cNvPr id="17" name="Shape 12"/>
+              <a:t>Alert triage, case graph, evidence, feedback loop</a:t>
+            </a:r>
+            <a:endParaRPr lang="en-US" sz="1100" dirty="0"/>
+          </a:p>
+        </p:txBody>
+      </p:sp>
+      <p:sp>
+        <p:nvSpPr>
+          <p:cNvPr id="23" name="Shape 18"/>
           <p:cNvSpPr/>
           <p:nvPr/>
         </p:nvSpPr>
         <p:spPr>
           <a:xfrm>
-            <a:off x="9061704" y="1965960"/>
-            <a:ext cx="2606040" cy="1371600"/>
+            <a:off x="640080" y="4937760"/>
+            <a:ext cx="10881360" cy="1097280"/>
           </a:xfrm>
           <a:prstGeom prst="roundRect">
             <a:avLst>
-              <a:gd name="adj" fmla="val 5333"/>
+              <a:gd name="adj" fmla="val 6667"/>
             </a:avLst>
           </a:prstGeom>
           <a:solidFill>
@@ -5485,7 +5683,7 @@
       </p:sp>
       <p:pic>
         <p:nvPicPr>
-          <p:cNvPr id="18" name="Image 3" descr="C:\Users\Dell\AppData\Local\Temp\claude\C--Users-Dell-Documents-chakravyuh\a4ec3c1a-964e-4574-a792-caf74a383059\scratchpad\virgil_ppt\icons\folderopen.png">    </p:cNvPr>
+          <p:cNvPr id="24" name="Image 3" descr="C:\Users\Dell\AppData\Local\Temp\claude\C--Users-Dell-Documents-chakravyuh\a4ec3c1a-964e-4574-a792-caf74a383059\scratchpad\virgil_ppt\icons\checkcircle.png">    </p:cNvPr>
           <p:cNvPicPr>
             <a:picLocks noChangeAspect="1"/>
           </p:cNvPicPr>
@@ -5499,8 +5697,8 @@
         </p:blipFill>
         <p:spPr>
           <a:xfrm>
-            <a:off x="9262872" y="2167128"/>
-            <a:ext cx="365760" cy="365760"/>
+            <a:off x="914400" y="5193792"/>
+            <a:ext cx="457200" cy="457200"/>
           </a:xfrm>
           <a:prstGeom prst="rect">
             <a:avLst/>
@@ -5509,14 +5707,14 @@
       </p:pic>
       <p:sp>
         <p:nvSpPr>
-          <p:cNvPr id="19" name="Text 13"/>
-          <p:cNvSpPr txBox="1"/>
-          <p:nvPr/>
-        </p:nvSpPr>
-        <p:spPr>
-          <a:xfrm>
-            <a:off x="9244584" y="2514600"/>
-            <a:ext cx="2240280" cy="502920"/>
+          <p:cNvPr id="25" name="Text 19"/>
+          <p:cNvSpPr txBox="1"/>
+          <p:nvPr/>
+        </p:nvSpPr>
+        <p:spPr>
+          <a:xfrm>
+            <a:off x="1554480" y="5193792"/>
+            <a:ext cx="9692640" cy="594360"/>
           </a:xfrm>
           <a:prstGeom prst="rect">
             <a:avLst/>
@@ -5532,159 +5730,7 @@
               <a:buNone/>
             </a:pPr>
             <a:r>
-              <a:rPr lang="en-US" sz="2200" b="1" dirty="0">
-                <a:solidFill>
-                  <a:srgbClr val="3B82F6"/>
-                </a:solidFill>
-                <a:latin typeface="Calibri" pitchFamily="34" charset="0"/>
-                <a:ea typeface="Calibri" pitchFamily="34" charset="-122"/>
-                <a:cs typeface="Calibri" pitchFamily="34" charset="-120"/>
-              </a:rPr>
-              <a:t>5</a:t>
-            </a:r>
-            <a:endParaRPr lang="en-US" sz="2200" dirty="0"/>
-          </a:p>
-        </p:txBody>
-      </p:sp>
-      <p:sp>
-        <p:nvSpPr>
-          <p:cNvPr id="20" name="Text 14"/>
-          <p:cNvSpPr txBox="1"/>
-          <p:nvPr/>
-        </p:nvSpPr>
-        <p:spPr>
-          <a:xfrm>
-            <a:off x="9244584" y="2990088"/>
-            <a:ext cx="2240280" cy="274320"/>
-          </a:xfrm>
-          <a:prstGeom prst="rect">
-            <a:avLst/>
-          </a:prstGeom>
-          <a:noFill/>
-          <a:ln/>
-        </p:spPr>
-        <p:txBody>
-          <a:bodyPr wrap="square" lIns="0" tIns="0" rIns="0" bIns="0" rtlCol="0" anchor="ctr"/>
-          <a:lstStyle/>
-          <a:p>
-            <a:pPr indent="0" marL="0">
-              <a:buNone/>
-            </a:pPr>
-            <a:r>
-              <a:rPr lang="en-US" sz="1000" dirty="0">
-                <a:solidFill>
-                  <a:srgbClr val="94A3B8"/>
-                </a:solidFill>
-                <a:latin typeface="Calibri" pitchFamily="34" charset="0"/>
-                <a:ea typeface="Calibri" pitchFamily="34" charset="-122"/>
-                <a:cs typeface="Calibri" pitchFamily="34" charset="-120"/>
-              </a:rPr>
-              <a:t>Active Cases</a:t>
-            </a:r>
-            <a:endParaRPr lang="en-US" sz="1000" dirty="0"/>
-          </a:p>
-        </p:txBody>
-      </p:sp>
-      <p:sp>
-        <p:nvSpPr>
-          <p:cNvPr id="21" name="Shape 15"/>
-          <p:cNvSpPr/>
-          <p:nvPr/>
-        </p:nvSpPr>
-        <p:spPr>
-          <a:xfrm>
-            <a:off x="640080" y="3611880"/>
-            <a:ext cx="3502152" cy="2331720"/>
-          </a:xfrm>
-          <a:prstGeom prst="roundRect">
-            <a:avLst>
-              <a:gd name="adj" fmla="val 3137"/>
-            </a:avLst>
-          </a:prstGeom>
-          <a:solidFill>
-            <a:srgbClr val="141B2E"/>
-          </a:solidFill>
-          <a:ln w="12700">
-            <a:solidFill>
-              <a:srgbClr val="223049"/>
-            </a:solidFill>
-            <a:prstDash val="solid"/>
-          </a:ln>
-        </p:spPr>
-      </p:sp>
-      <p:sp>
-        <p:nvSpPr>
-          <p:cNvPr id="22" name="Shape 16"/>
-          <p:cNvSpPr/>
-          <p:nvPr/>
-        </p:nvSpPr>
-        <p:spPr>
-          <a:xfrm>
-            <a:off x="868680" y="3840480"/>
-            <a:ext cx="548640" cy="548640"/>
-          </a:xfrm>
-          <a:prstGeom prst="ellipse">
-            <a:avLst/>
-          </a:prstGeom>
-          <a:solidFill>
-            <a:srgbClr val="1D3B66"/>
-          </a:solidFill>
-          <a:ln/>
-        </p:spPr>
-      </p:sp>
-      <p:pic>
-        <p:nvPicPr>
-          <p:cNvPr id="23" name="Image 4" descr="C:\Users\Dell\AppData\Local\Temp\claude\C--Users-Dell-Documents-chakravyuh\a4ec3c1a-964e-4574-a792-caf74a383059\scratchpad\virgil_ppt\icons\linechart.png">    </p:cNvPr>
-          <p:cNvPicPr>
-            <a:picLocks noChangeAspect="1"/>
-          </p:cNvPicPr>
-          <p:nvPr/>
-        </p:nvPicPr>
-        <p:blipFill>
-          <a:blip r:embed="rId5"/>
-          <a:stretch>
-            <a:fillRect/>
-          </a:stretch>
-        </p:blipFill>
-        <p:spPr>
-          <a:xfrm>
-            <a:off x="1011326" y="3983126"/>
-            <a:ext cx="263347" cy="263347"/>
-          </a:xfrm>
-          <a:prstGeom prst="rect">
-            <a:avLst/>
-          </a:prstGeom>
-        </p:spPr>
-      </p:pic>
-      <p:sp>
-        <p:nvSpPr>
-          <p:cNvPr id="24" name="Text 17"/>
-          <p:cNvSpPr txBox="1"/>
-          <p:nvPr/>
-        </p:nvSpPr>
-        <p:spPr>
-          <a:xfrm>
-            <a:off x="868680" y="4526280"/>
-            <a:ext cx="3044952" cy="548640"/>
-          </a:xfrm>
-          <a:prstGeom prst="rect">
-            <a:avLst/>
-          </a:prstGeom>
-          <a:noFill/>
-          <a:ln/>
-        </p:spPr>
-        <p:txBody>
-          <a:bodyPr wrap="square" lIns="0" tIns="0" rIns="0" bIns="0" rtlCol="0" anchor="ctr"/>
-          <a:lstStyle/>
-          <a:p>
-            <a:pPr indent="0" marL="0">
-              <a:lnSpc>
-                <a:spcPct val="110000"/>
-              </a:lnSpc>
-              <a:buNone/>
-            </a:pPr>
-            <a:r>
-              <a:rPr lang="en-US" sz="1300" b="1" dirty="0">
+              <a:rPr lang="en-US" sz="1300" dirty="0">
                 <a:solidFill>
                   <a:srgbClr val="F1F5F9"/>
                 </a:solidFill>
@@ -5692,7 +5738,7 @@
                 <a:ea typeface="Calibri" pitchFamily="34" charset="-122"/>
                 <a:cs typeface="Calibri" pitchFamily="34" charset="-120"/>
               </a:rPr>
-              <a:t>Fraud Intelligence Trend</a:t>
+              <a:t>Every run shows the full pipeline: risk signals in, decision out — the same engine GPay calls, exercised on demand.</a:t>
             </a:r>
             <a:endParaRPr lang="en-US" sz="1300" dirty="0"/>
           </a:p>
@@ -5700,359 +5746,7 @@
       </p:sp>
       <p:sp>
         <p:nvSpPr>
-          <p:cNvPr id="25" name="Text 18"/>
-          <p:cNvSpPr txBox="1"/>
-          <p:nvPr/>
-        </p:nvSpPr>
-        <p:spPr>
-          <a:xfrm>
-            <a:off x="868680" y="5074920"/>
-            <a:ext cx="3044952" cy="777240"/>
-          </a:xfrm>
-          <a:prstGeom prst="rect">
-            <a:avLst/>
-          </a:prstGeom>
-          <a:noFill/>
-          <a:ln/>
-        </p:spPr>
-        <p:txBody>
-          <a:bodyPr wrap="square" lIns="0" tIns="0" rIns="0" bIns="0" rtlCol="0" anchor="ctr"/>
-          <a:lstStyle/>
-          <a:p>
-            <a:pPr indent="0" marL="0">
-              <a:lnSpc>
-                <a:spcPct val="120000"/>
-              </a:lnSpc>
-              <a:buNone/>
-            </a:pPr>
-            <a:r>
-              <a:rPr lang="en-US" sz="1050" dirty="0">
-                <a:solidFill>
-                  <a:srgbClr val="94A3B8"/>
-                </a:solidFill>
-                <a:latin typeface="Calibri" pitchFamily="34" charset="0"/>
-                <a:ea typeface="Calibri" pitchFamily="34" charset="-122"/>
-                <a:cs typeface="Calibri" pitchFamily="34" charset="-120"/>
-              </a:rPr>
-              <a:t>Monthly detected vs. prevented, side by side</a:t>
-            </a:r>
-            <a:endParaRPr lang="en-US" sz="1050" dirty="0"/>
-          </a:p>
-        </p:txBody>
-      </p:sp>
-      <p:sp>
-        <p:nvSpPr>
-          <p:cNvPr id="26" name="Shape 19"/>
-          <p:cNvSpPr/>
-          <p:nvPr/>
-        </p:nvSpPr>
-        <p:spPr>
-          <a:xfrm>
-            <a:off x="4325112" y="3611880"/>
-            <a:ext cx="3502152" cy="2331720"/>
-          </a:xfrm>
-          <a:prstGeom prst="roundRect">
-            <a:avLst>
-              <a:gd name="adj" fmla="val 3137"/>
-            </a:avLst>
-          </a:prstGeom>
-          <a:solidFill>
-            <a:srgbClr val="141B2E"/>
-          </a:solidFill>
-          <a:ln w="12700">
-            <a:solidFill>
-              <a:srgbClr val="223049"/>
-            </a:solidFill>
-            <a:prstDash val="solid"/>
-          </a:ln>
-        </p:spPr>
-      </p:sp>
-      <p:sp>
-        <p:nvSpPr>
-          <p:cNvPr id="27" name="Shape 20"/>
-          <p:cNvSpPr/>
-          <p:nvPr/>
-        </p:nvSpPr>
-        <p:spPr>
-          <a:xfrm>
-            <a:off x="4553712" y="3840480"/>
-            <a:ext cx="548640" cy="548640"/>
-          </a:xfrm>
-          <a:prstGeom prst="ellipse">
-            <a:avLst/>
-          </a:prstGeom>
-          <a:solidFill>
-            <a:srgbClr val="1D3B66"/>
-          </a:solidFill>
-          <a:ln/>
-        </p:spPr>
-      </p:sp>
-      <p:pic>
-        <p:nvPicPr>
-          <p:cNvPr id="28" name="Image 5" descr="C:\Users\Dell\AppData\Local\Temp\claude\C--Users-Dell-Documents-chakravyuh\a4ec3c1a-964e-4574-a792-caf74a383059\scratchpad\virgil_ppt\icons\scale.png">    </p:cNvPr>
-          <p:cNvPicPr>
-            <a:picLocks noChangeAspect="1"/>
-          </p:cNvPicPr>
-          <p:nvPr/>
-        </p:nvPicPr>
-        <p:blipFill>
-          <a:blip r:embed="rId6"/>
-          <a:stretch>
-            <a:fillRect/>
-          </a:stretch>
-        </p:blipFill>
-        <p:spPr>
-          <a:xfrm>
-            <a:off x="4696358" y="3983126"/>
-            <a:ext cx="263347" cy="263347"/>
-          </a:xfrm>
-          <a:prstGeom prst="rect">
-            <a:avLst/>
-          </a:prstGeom>
-        </p:spPr>
-      </p:pic>
-      <p:sp>
-        <p:nvSpPr>
-          <p:cNvPr id="29" name="Text 21"/>
-          <p:cNvSpPr txBox="1"/>
-          <p:nvPr/>
-        </p:nvSpPr>
-        <p:spPr>
-          <a:xfrm>
-            <a:off x="4553712" y="4526280"/>
-            <a:ext cx="3044952" cy="548640"/>
-          </a:xfrm>
-          <a:prstGeom prst="rect">
-            <a:avLst/>
-          </a:prstGeom>
-          <a:noFill/>
-          <a:ln/>
-        </p:spPr>
-        <p:txBody>
-          <a:bodyPr wrap="square" lIns="0" tIns="0" rIns="0" bIns="0" rtlCol="0" anchor="ctr"/>
-          <a:lstStyle/>
-          <a:p>
-            <a:pPr indent="0" marL="0">
-              <a:lnSpc>
-                <a:spcPct val="110000"/>
-              </a:lnSpc>
-              <a:buNone/>
-            </a:pPr>
-            <a:r>
-              <a:rPr lang="en-US" sz="1300" b="1" dirty="0">
-                <a:solidFill>
-                  <a:srgbClr val="F1F5F9"/>
-                </a:solidFill>
-                <a:latin typeface="Calibri" pitchFamily="34" charset="0"/>
-                <a:ea typeface="Calibri" pitchFamily="34" charset="-122"/>
-                <a:cs typeface="Calibri" pitchFamily="34" charset="-120"/>
-              </a:rPr>
-              <a:t>Compliance &amp; STR/CTR</a:t>
-            </a:r>
-            <a:endParaRPr lang="en-US" sz="1300" dirty="0"/>
-          </a:p>
-        </p:txBody>
-      </p:sp>
-      <p:sp>
-        <p:nvSpPr>
-          <p:cNvPr id="30" name="Text 22"/>
-          <p:cNvSpPr txBox="1"/>
-          <p:nvPr/>
-        </p:nvSpPr>
-        <p:spPr>
-          <a:xfrm>
-            <a:off x="4553712" y="5074920"/>
-            <a:ext cx="3044952" cy="777240"/>
-          </a:xfrm>
-          <a:prstGeom prst="rect">
-            <a:avLst/>
-          </a:prstGeom>
-          <a:noFill/>
-          <a:ln/>
-        </p:spPr>
-        <p:txBody>
-          <a:bodyPr wrap="square" lIns="0" tIns="0" rIns="0" bIns="0" rtlCol="0" anchor="ctr"/>
-          <a:lstStyle/>
-          <a:p>
-            <a:pPr indent="0" marL="0">
-              <a:lnSpc>
-                <a:spcPct val="120000"/>
-              </a:lnSpc>
-              <a:buNone/>
-            </a:pPr>
-            <a:r>
-              <a:rPr lang="en-US" sz="1050" dirty="0">
-                <a:solidFill>
-                  <a:srgbClr val="94A3B8"/>
-                </a:solidFill>
-                <a:latin typeface="Calibri" pitchFamily="34" charset="0"/>
-                <a:ea typeface="Calibri" pitchFamily="34" charset="-122"/>
-                <a:cs typeface="Calibri" pitchFamily="34" charset="-120"/>
-              </a:rPr>
-              <a:t>STR filing status, PMLA 2002 obligations, audit score</a:t>
-            </a:r>
-            <a:endParaRPr lang="en-US" sz="1050" dirty="0"/>
-          </a:p>
-        </p:txBody>
-      </p:sp>
-      <p:sp>
-        <p:nvSpPr>
-          <p:cNvPr id="31" name="Shape 23"/>
-          <p:cNvSpPr/>
-          <p:nvPr/>
-        </p:nvSpPr>
-        <p:spPr>
-          <a:xfrm>
-            <a:off x="8010144" y="3611880"/>
-            <a:ext cx="3502152" cy="2331720"/>
-          </a:xfrm>
-          <a:prstGeom prst="roundRect">
-            <a:avLst>
-              <a:gd name="adj" fmla="val 3137"/>
-            </a:avLst>
-          </a:prstGeom>
-          <a:solidFill>
-            <a:srgbClr val="141B2E"/>
-          </a:solidFill>
-          <a:ln w="12700">
-            <a:solidFill>
-              <a:srgbClr val="223049"/>
-            </a:solidFill>
-            <a:prstDash val="solid"/>
-          </a:ln>
-        </p:spPr>
-      </p:sp>
-      <p:sp>
-        <p:nvSpPr>
-          <p:cNvPr id="32" name="Shape 24"/>
-          <p:cNvSpPr/>
-          <p:nvPr/>
-        </p:nvSpPr>
-        <p:spPr>
-          <a:xfrm>
-            <a:off x="8238744" y="3840480"/>
-            <a:ext cx="548640" cy="548640"/>
-          </a:xfrm>
-          <a:prstGeom prst="ellipse">
-            <a:avLst/>
-          </a:prstGeom>
-          <a:solidFill>
-            <a:srgbClr val="1D3B66"/>
-          </a:solidFill>
-          <a:ln/>
-        </p:spPr>
-      </p:sp>
-      <p:pic>
-        <p:nvPicPr>
-          <p:cNvPr id="33" name="Image 6" descr="C:\Users\Dell\AppData\Local\Temp\claude\C--Users-Dell-Documents-chakravyuh\a4ec3c1a-964e-4574-a792-caf74a383059\scratchpad\virgil_ppt\icons\gauge.png">    </p:cNvPr>
-          <p:cNvPicPr>
-            <a:picLocks noChangeAspect="1"/>
-          </p:cNvPicPr>
-          <p:nvPr/>
-        </p:nvPicPr>
-        <p:blipFill>
-          <a:blip r:embed="rId7"/>
-          <a:stretch>
-            <a:fillRect/>
-          </a:stretch>
-        </p:blipFill>
-        <p:spPr>
-          <a:xfrm>
-            <a:off x="8381390" y="3983126"/>
-            <a:ext cx="263347" cy="263347"/>
-          </a:xfrm>
-          <a:prstGeom prst="rect">
-            <a:avLst/>
-          </a:prstGeom>
-        </p:spPr>
-      </p:pic>
-      <p:sp>
-        <p:nvSpPr>
-          <p:cNvPr id="34" name="Text 25"/>
-          <p:cNvSpPr txBox="1"/>
-          <p:nvPr/>
-        </p:nvSpPr>
-        <p:spPr>
-          <a:xfrm>
-            <a:off x="8238744" y="4526280"/>
-            <a:ext cx="3044952" cy="548640"/>
-          </a:xfrm>
-          <a:prstGeom prst="rect">
-            <a:avLst/>
-          </a:prstGeom>
-          <a:noFill/>
-          <a:ln/>
-        </p:spPr>
-        <p:txBody>
-          <a:bodyPr wrap="square" lIns="0" tIns="0" rIns="0" bIns="0" rtlCol="0" anchor="ctr"/>
-          <a:lstStyle/>
-          <a:p>
-            <a:pPr indent="0" marL="0">
-              <a:lnSpc>
-                <a:spcPct val="110000"/>
-              </a:lnSpc>
-              <a:buNone/>
-            </a:pPr>
-            <a:r>
-              <a:rPr lang="en-US" sz="1300" b="1" dirty="0">
-                <a:solidFill>
-                  <a:srgbClr val="F1F5F9"/>
-                </a:solidFill>
-                <a:latin typeface="Calibri" pitchFamily="34" charset="0"/>
-                <a:ea typeface="Calibri" pitchFamily="34" charset="-122"/>
-                <a:cs typeface="Calibri" pitchFamily="34" charset="-120"/>
-              </a:rPr>
-              <a:t>Model Health</a:t>
-            </a:r>
-            <a:endParaRPr lang="en-US" sz="1300" dirty="0"/>
-          </a:p>
-        </p:txBody>
-      </p:sp>
-      <p:sp>
-        <p:nvSpPr>
-          <p:cNvPr id="35" name="Text 26"/>
-          <p:cNvSpPr txBox="1"/>
-          <p:nvPr/>
-        </p:nvSpPr>
-        <p:spPr>
-          <a:xfrm>
-            <a:off x="8238744" y="5074920"/>
-            <a:ext cx="3044952" cy="777240"/>
-          </a:xfrm>
-          <a:prstGeom prst="rect">
-            <a:avLst/>
-          </a:prstGeom>
-          <a:noFill/>
-          <a:ln/>
-        </p:spPr>
-        <p:txBody>
-          <a:bodyPr wrap="square" lIns="0" tIns="0" rIns="0" bIns="0" rtlCol="0" anchor="ctr"/>
-          <a:lstStyle/>
-          <a:p>
-            <a:pPr indent="0" marL="0">
-              <a:lnSpc>
-                <a:spcPct val="120000"/>
-              </a:lnSpc>
-              <a:buNone/>
-            </a:pPr>
-            <a:r>
-              <a:rPr lang="en-US" sz="1050" dirty="0">
-                <a:solidFill>
-                  <a:srgbClr val="94A3B8"/>
-                </a:solidFill>
-                <a:latin typeface="Calibri" pitchFamily="34" charset="0"/>
-                <a:ea typeface="Calibri" pitchFamily="34" charset="-122"/>
-                <a:cs typeface="Calibri" pitchFamily="34" charset="-120"/>
-              </a:rPr>
-              <a:t>Precision, recall, F1, and live data-drift monitoring</a:t>
-            </a:r>
-            <a:endParaRPr lang="en-US" sz="1050" dirty="0"/>
-          </a:p>
-        </p:txBody>
-      </p:sp>
-      <p:sp>
-        <p:nvSpPr>
-          <p:cNvPr id="36" name="Text 27"/>
+          <p:cNvPr id="26" name="Text 20"/>
           <p:cNvSpPr txBox="1"/>
           <p:nvPr/>
         </p:nvSpPr>
@@ -7564,7 +7258,7 @@
                 <a:ea typeface="Calibri" pitchFamily="34" charset="-122"/>
                 <a:cs typeface="Calibri" pitchFamily="34" charset="-120"/>
               </a:rPr>
-              <a:t>Then we’ll walk through the Analyst Console and Executive Dashboard the same transaction feeds into.</a:t>
+              <a:t>Then we’ll walk through the Analyst Console the same transaction feeds into — and the test simulator that fires all of this on demand.</a:t>
             </a:r>
             <a:endParaRPr lang="en-US" sz="1300" dirty="0"/>
           </a:p>
@@ -7761,7 +7455,7 @@
       </p:sp>
       <p:pic>
         <p:nvPicPr>
-          <p:cNvPr id="6" name="Image 0" descr="C:\Users\Dell\AppData\Local\Temp\claude\C--Users-Dell-Documents-chakravyuh\a4ec3c1a-964e-4574-a792-caf74a383059\scratchpad\virgil_ppt\icons\sparkles.png">    </p:cNvPr>
+          <p:cNvPr id="6" name="Image 0" descr="C:\Users\Dell\AppData\Local\Temp\claude\C--Users-Dell-Documents-chakravyuh\a4ec3c1a-964e-4574-a792-caf74a383059\scratchpad\virgil_ppt\icons\barchart.png">    </p:cNvPr>
           <p:cNvPicPr>
             <a:picLocks noChangeAspect="1"/>
           </p:cNvPicPr>
@@ -7819,7 +7513,7 @@
                 <a:ea typeface="Calibri" pitchFamily="34" charset="-122"/>
                 <a:cs typeface="Calibri" pitchFamily="34" charset="-120"/>
               </a:rPr>
-              <a:t>Activate AI Explanations</a:t>
+              <a:t>Executive &amp; Leadership Dashboard</a:t>
             </a:r>
             <a:endParaRPr lang="en-US" sz="1250" dirty="0"/>
           </a:p>
@@ -7861,7 +7555,7 @@
                 <a:ea typeface="Calibri" pitchFamily="34" charset="-122"/>
                 <a:cs typeface="Calibri" pitchFamily="34" charset="-120"/>
               </a:rPr>
-              <a:t>Turn on GPT-4o mini with a real API key — live alert briefings, case summaries, and FIU-IND report narratives</a:t>
+              <a:t>Board-level KPIs, STR/CTR compliance tracking, and model-health monitoring — built, held back for this round</a:t>
             </a:r>
             <a:endParaRPr lang="en-US" sz="1000" dirty="0"/>
           </a:p>
@@ -7916,7 +7610,7 @@
       </p:sp>
       <p:pic>
         <p:nvPicPr>
-          <p:cNvPr id="11" name="Image 1" descr="C:\Users\Dell\AppData\Local\Temp\claude\C--Users-Dell-Documents-chakravyuh\a4ec3c1a-964e-4574-a792-caf74a383059\scratchpad\virgil_ppt\icons\filetext.png">    </p:cNvPr>
+          <p:cNvPr id="11" name="Image 1" descr="C:\Users\Dell\AppData\Local\Temp\claude\C--Users-Dell-Documents-chakravyuh\a4ec3c1a-964e-4574-a792-caf74a383059\scratchpad\virgil_ppt\icons\sparkles.png">    </p:cNvPr>
           <p:cNvPicPr>
             <a:picLocks noChangeAspect="1"/>
           </p:cNvPicPr>
@@ -7974,7 +7668,7 @@
                 <a:ea typeface="Calibri" pitchFamily="34" charset="-122"/>
                 <a:cs typeface="Calibri" pitchFamily="34" charset="-120"/>
               </a:rPr>
-              <a:t>Automated Regulatory Reporting</a:t>
+              <a:t>Activate AI Explanations</a:t>
             </a:r>
             <a:endParaRPr lang="en-US" sz="1250" dirty="0"/>
           </a:p>
@@ -8016,7 +7710,7 @@
                 <a:ea typeface="Calibri" pitchFamily="34" charset="-122"/>
                 <a:cs typeface="Calibri" pitchFamily="34" charset="-120"/>
               </a:rPr>
-              <a:t>One-click STR/SAR filing package generation, fully formatted for FIU-IND submission</a:t>
+              <a:t>Turn on GPT-4o mini with a real API key — live alert briefings, case summaries, and FIU-IND report narratives</a:t>
             </a:r>
             <a:endParaRPr lang="en-US" sz="1000" dirty="0"/>
           </a:p>
@@ -8071,7 +7765,7 @@
       </p:sp>
       <p:pic>
         <p:nvPicPr>
-          <p:cNvPr id="16" name="Image 2" descr="C:\Users\Dell\AppData\Local\Temp\claude\C--Users-Dell-Documents-chakravyuh\a4ec3c1a-964e-4574-a792-caf74a383059\scratchpad\virgil_ppt\icons\brain.png">    </p:cNvPr>
+          <p:cNvPr id="16" name="Image 2" descr="C:\Users\Dell\AppData\Local\Temp\claude\C--Users-Dell-Documents-chakravyuh\a4ec3c1a-964e-4574-a792-caf74a383059\scratchpad\virgil_ppt\icons\filetext.png">    </p:cNvPr>
           <p:cNvPicPr>
             <a:picLocks noChangeAspect="1"/>
           </p:cNvPicPr>
@@ -8129,7 +7823,7 @@
                 <a:ea typeface="Calibri" pitchFamily="34" charset="-122"/>
                 <a:cs typeface="Calibri" pitchFamily="34" charset="-120"/>
               </a:rPr>
-              <a:t>Learned Risk Weights</a:t>
+              <a:t>Automated Regulatory Reporting</a:t>
             </a:r>
             <a:endParaRPr lang="en-US" sz="1250" dirty="0"/>
           </a:p>
@@ -8171,7 +7865,7 @@
                 <a:ea typeface="Calibri" pitchFamily="34" charset="-122"/>
                 <a:cs typeface="Calibri" pitchFamily="34" charset="-120"/>
               </a:rPr>
-              <a:t>Feed analyst feedback (confirmed fraud / false positive) back into the engine to tune signal weights over time</a:t>
+              <a:t>One-click STR/SAR filing package generation, fully formatted for FIU-IND submission</a:t>
             </a:r>
             <a:endParaRPr lang="en-US" sz="1000" dirty="0"/>
           </a:p>
@@ -8226,7 +7920,7 @@
       </p:sp>
       <p:pic>
         <p:nvPicPr>
-          <p:cNvPr id="21" name="Image 3" descr="C:\Users\Dell\AppData\Local\Temp\claude\C--Users-Dell-Documents-chakravyuh\a4ec3c1a-964e-4574-a792-caf74a383059\scratchpad\virgil_ppt\icons\network.png">    </p:cNvPr>
+          <p:cNvPr id="21" name="Image 3" descr="C:\Users\Dell\AppData\Local\Temp\claude\C--Users-Dell-Documents-chakravyuh\a4ec3c1a-964e-4574-a792-caf74a383059\scratchpad\virgil_ppt\icons\brain.png">    </p:cNvPr>
           <p:cNvPicPr>
             <a:picLocks noChangeAspect="1"/>
           </p:cNvPicPr>
@@ -8284,7 +7978,7 @@
                 <a:ea typeface="Calibri" pitchFamily="34" charset="-122"/>
                 <a:cs typeface="Calibri" pitchFamily="34" charset="-120"/>
               </a:rPr>
-              <a:t>Deeper Graph Intelligence</a:t>
+              <a:t>Learned Risk Weights</a:t>
             </a:r>
             <a:endParaRPr lang="en-US" sz="1250" dirty="0"/>
           </a:p>
@@ -8326,7 +8020,7 @@
                 <a:ea typeface="Calibri" pitchFamily="34" charset="-122"/>
                 <a:cs typeface="Calibri" pitchFamily="34" charset="-120"/>
               </a:rPr>
-              <a:t>Multi-hop mule network detection, centrality analysis, cross-bank account linking</a:t>
+              <a:t>Feed analyst feedback (confirmed fraud / false positive) back into the engine to tune signal weights over time</a:t>
             </a:r>
             <a:endParaRPr lang="en-US" sz="1000" dirty="0"/>
           </a:p>
@@ -8381,7 +8075,7 @@
       </p:sp>
       <p:pic>
         <p:nvPicPr>
-          <p:cNvPr id="26" name="Image 4" descr="C:\Users\Dell\AppData\Local\Temp\claude\C--Users-Dell-Documents-chakravyuh\a4ec3c1a-964e-4574-a792-caf74a383059\scratchpad\virgil_ppt\icons\database.png">    </p:cNvPr>
+          <p:cNvPr id="26" name="Image 4" descr="C:\Users\Dell\AppData\Local\Temp\claude\C--Users-Dell-Documents-chakravyuh\a4ec3c1a-964e-4574-a792-caf74a383059\scratchpad\virgil_ppt\icons\network.png">    </p:cNvPr>
           <p:cNvPicPr>
             <a:picLocks noChangeAspect="1"/>
           </p:cNvPicPr>
@@ -8439,7 +8133,7 @@
                 <a:ea typeface="Calibri" pitchFamily="34" charset="-122"/>
                 <a:cs typeface="Calibri" pitchFamily="34" charset="-120"/>
               </a:rPr>
-              <a:t>Production Database</a:t>
+              <a:t>Deeper Graph Intelligence</a:t>
             </a:r>
             <a:endParaRPr lang="en-US" sz="1250" dirty="0"/>
           </a:p>
@@ -8481,7 +8175,7 @@
                 <a:ea typeface="Calibri" pitchFamily="34" charset="-122"/>
                 <a:cs typeface="Calibri" pitchFamily="34" charset="-120"/>
               </a:rPr>
-              <a:t>Move from in-memory JSON to PostgreSQL with real transaction volume and history</a:t>
+              <a:t>Multi-hop mule network detection, centrality analysis, cross-bank account linking</a:t>
             </a:r>
             <a:endParaRPr lang="en-US" sz="1000" dirty="0"/>
           </a:p>
@@ -8536,7 +8230,7 @@
       </p:sp>
       <p:pic>
         <p:nvPicPr>
-          <p:cNvPr id="31" name="Image 5" descr="C:\Users\Dell\AppData\Local\Temp\claude\C--Users-Dell-Documents-chakravyuh\a4ec3c1a-964e-4574-a792-caf74a383059\scratchpad\virgil_ppt\icons\globe.png">    </p:cNvPr>
+          <p:cNvPr id="31" name="Image 5" descr="C:\Users\Dell\AppData\Local\Temp\claude\C--Users-Dell-Documents-chakravyuh\a4ec3c1a-964e-4574-a792-caf74a383059\scratchpad\virgil_ppt\icons\database.png">    </p:cNvPr>
           <p:cNvPicPr>
             <a:picLocks noChangeAspect="1"/>
           </p:cNvPicPr>
@@ -8594,7 +8288,7 @@
                 <a:ea typeface="Calibri" pitchFamily="34" charset="-122"/>
                 <a:cs typeface="Calibri" pitchFamily="34" charset="-120"/>
               </a:rPr>
-              <a:t>Multi-Bank / Multi-Channel</a:t>
+              <a:t>Production Database</a:t>
             </a:r>
             <a:endParaRPr lang="en-US" sz="1250" dirty="0"/>
           </a:p>
@@ -8636,7 +8330,7 @@
                 <a:ea typeface="Calibri" pitchFamily="34" charset="-122"/>
                 <a:cs typeface="Calibri" pitchFamily="34" charset="-120"/>
               </a:rPr>
-              <a:t>Extend beyond UPI to cards, NEFT/RTGS, and cross-institution transaction sharing</a:t>
+              <a:t>Move from in-memory JSON to PostgreSQL with real transaction volume and history</a:t>
             </a:r>
             <a:endParaRPr lang="en-US" sz="1000" dirty="0"/>
           </a:p>
@@ -9872,7 +9566,7 @@
                 <a:ea typeface="Calibri" pitchFamily="34" charset="-122"/>
                 <a:cs typeface="Calibri" pitchFamily="34" charset="-120"/>
               </a:rPr>
-              <a:t>A full-stack fraud intelligence platform: a mock banking payment app that scores every transaction in real time, plus the analyst and executive consoles a bank’s fraud team would actually use.</a:t>
+              <a:t>A full-stack fraud intelligence platform: a mock banking payment app that scores every transaction in real time, plus the analyst investigation console a bank’s fraud team would actually use.</a:t>
             </a:r>
             <a:endParaRPr lang="en-US" sz="1400" dirty="0"/>
           </a:p>
@@ -10383,7 +10077,7 @@
       </p:sp>
       <p:pic>
         <p:nvPicPr>
-          <p:cNvPr id="22" name="Image 3" descr="C:\Users\Dell\AppData\Local\Temp\claude\C--Users-Dell-Documents-chakravyuh\a4ec3c1a-964e-4574-a792-caf74a383059\scratchpad\virgil_ppt\icons\barchart.png">    </p:cNvPr>
+          <p:cNvPr id="22" name="Image 3" descr="C:\Users\Dell\AppData\Local\Temp\claude\C--Users-Dell-Documents-chakravyuh\a4ec3c1a-964e-4574-a792-caf74a383059\scratchpad\virgil_ppt\icons\target.png">    </p:cNvPr>
           <p:cNvPicPr>
             <a:picLocks noChangeAspect="1"/>
           </p:cNvPicPr>
@@ -10438,7 +10132,7 @@
                 <a:ea typeface="Calibri" pitchFamily="34" charset="-122"/>
                 <a:cs typeface="Calibri" pitchFamily="34" charset="-120"/>
               </a:rPr>
-              <a:t>Executive Dashboard</a:t>
+              <a:t>34 Live Test Scenarios</a:t>
             </a:r>
             <a:endParaRPr lang="en-US" sz="1500" dirty="0"/>
           </a:p>
@@ -10480,7 +10174,7 @@
                 <a:ea typeface="Calibri" pitchFamily="34" charset="-122"/>
                 <a:cs typeface="Calibri" pitchFamily="34" charset="-120"/>
               </a:rPr>
-              <a:t>Fraud KPIs, compliance (STR/CTR), model health &amp; drift monitoring</a:t>
+              <a:t>A built-in simulator that fires real API calls across every fraud pattern on demand</a:t>
             </a:r>
             <a:endParaRPr lang="en-US" sz="1150" dirty="0"/>
           </a:p>
@@ -10971,7 +10665,7 @@
                 <a:ea typeface="Calibri" pitchFamily="34" charset="-122"/>
                 <a:cs typeface="Calibri" pitchFamily="34" charset="-120"/>
               </a:rPr>
-              <a:t>Analyst dashboard</a:t>
+              <a:t>Analyst console</a:t>
             </a:r>
             <a:endParaRPr lang="en-US" sz="1150" dirty="0"/>
           </a:p>
@@ -11030,7 +10724,7 @@
                 <a:ea typeface="Calibri" pitchFamily="34" charset="-122"/>
                 <a:cs typeface="Calibri" pitchFamily="34" charset="-120"/>
               </a:rPr>
-              <a:t>Executive dashboard</a:t>
+              <a:t>Test case simulator</a:t>
             </a:r>
             <a:endParaRPr lang="en-US" sz="1150" dirty="0"/>
           </a:p>

</xml_diff>